<commit_message>
feat: Implement deep-dive redirect tracing for LotL SAML attacks, fix Opera GX extension size
</commit_message>
<xml_diff>
--- a/documents/SentinURL Final Presentation.pptx
+++ b/documents/SentinURL Final Presentation.pptx
@@ -24,11 +24,10 @@
     <p:sldId id="269" r:id="rId15"/>
     <p:sldId id="270" r:id="rId16"/>
     <p:sldId id="271" r:id="rId17"/>
-    <p:sldId id="272" r:id="rId18"/>
-    <p:sldId id="273" r:id="rId19"/>
-    <p:sldId id="274" r:id="rId20"/>
-    <p:sldId id="275" r:id="rId21"/>
-    <p:sldId id="276" r:id="rId27"/>
+    <p:sldId id="273" r:id="rId18"/>
+    <p:sldId id="274" r:id="rId19"/>
+    <p:sldId id="275" r:id="rId20"/>
+    <p:sldId id="276" r:id="rId21"/>
   </p:sldIdLst>
   <p:sldSz cx="9144000" cy="6858000" type="screen4x3"/>
   <p:notesSz cx="6858000" cy="9144000"/>
@@ -831,76 +830,6 @@
 </p:notes>
 </file>
 
-<file path=ppt/notesSlides/notesSlide17.xml><?xml version="1.0" encoding="utf-8"?>
-<p:notes xmlns:a="http://schemas.openxmlformats.org/drawingml/2006/main" xmlns:r="http://schemas.openxmlformats.org/officeDocument/2006/relationships" xmlns:p="http://schemas.openxmlformats.org/presentationml/2006/main">
-  <p:cSld>
-    <p:spTree>
-      <p:nvGrpSpPr>
-        <p:cNvPr id="1" name=""/>
-        <p:cNvGrpSpPr/>
-        <p:nvPr/>
-      </p:nvGrpSpPr>
-      <p:grpSpPr>
-        <a:xfrm>
-          <a:off x="0" y="0"/>
-          <a:ext cx="0" cy="0"/>
-          <a:chOff x="0" y="0"/>
-          <a:chExt cx="0" cy="0"/>
-        </a:xfrm>
-      </p:grpSpPr>
-      <p:sp>
-        <p:nvSpPr>
-          <p:cNvPr id="2" name="Slide Image Placeholder 1"/>
-          <p:cNvSpPr>
-            <a:spLocks noGrp="1" noRot="1" noChangeAspect="1"/>
-          </p:cNvSpPr>
-          <p:nvPr>
-            <p:ph type="sldImg" idx="2"/>
-          </p:nvPr>
-        </p:nvSpPr>
-        <p:spPr/>
-      </p:sp>
-      <p:sp>
-        <p:nvSpPr>
-          <p:cNvPr id="3" name="Notes Placeholder 2"/>
-          <p:cNvSpPr>
-            <a:spLocks noGrp="1"/>
-          </p:cNvSpPr>
-          <p:nvPr>
-            <p:ph type="body" sz="quarter" idx="3"/>
-          </p:nvPr>
-        </p:nvSpPr>
-        <p:spPr/>
-        <p:txBody>
-          <a:bodyPr/>
-          <a:lstStyle/>
-          <a:p>
-            <a:r>
-              <a:t>I'm happy to answer any questions about the methodology, implementation details, or results. Common questions: How does it handle internationalized domains? Can it detect zero-day attacks on mobile apps? What's the training time for model updates?</a:t>
-            </a:r>
-          </a:p>
-        </p:txBody>
-      </p:sp>
-      <p:sp>
-        <p:nvSpPr>
-          <p:cNvPr id="4" name="Slide Number Placeholder 3"/>
-          <p:cNvSpPr>
-            <a:spLocks noGrp="1"/>
-          </p:cNvSpPr>
-          <p:nvPr>
-            <p:ph type="sldNum" sz="quarter" idx="5"/>
-          </p:nvPr>
-        </p:nvSpPr>
-        <p:spPr/>
-      </p:sp>
-    </p:spTree>
-  </p:cSld>
-  <p:clrMapOvr>
-    <a:masterClrMapping/>
-  </p:clrMapOvr>
-</p:notes>
-</file>
-
 <file path=ppt/notesSlides/notesSlide2.xml><?xml version="1.0" encoding="utf-8"?>
 <p:notes xmlns:a="http://schemas.openxmlformats.org/drawingml/2006/main" xmlns:r="http://schemas.openxmlformats.org/officeDocument/2006/relationships" xmlns:p="http://schemas.openxmlformats.org/presentationml/2006/main">
   <p:cSld>
@@ -1640,7 +1569,7 @@
           <a:p>
             <a:fld id="{5BCAD085-E8A6-8845-BD4E-CB4CCA059FC4}" type="datetimeFigureOut">
               <a:rPr lang="en-US" smtClean="0"/>
-              <a:t>3/10/2026</a:t>
+              <a:t>4/10/2026</a:t>
             </a:fld>
             <a:endParaRPr lang="en-US"/>
           </a:p>
@@ -1808,7 +1737,7 @@
           <a:p>
             <a:fld id="{5BCAD085-E8A6-8845-BD4E-CB4CCA059FC4}" type="datetimeFigureOut">
               <a:rPr lang="en-US" smtClean="0"/>
-              <a:t>3/10/2026</a:t>
+              <a:t>4/10/2026</a:t>
             </a:fld>
             <a:endParaRPr lang="en-US"/>
           </a:p>
@@ -1986,7 +1915,7 @@
           <a:p>
             <a:fld id="{5BCAD085-E8A6-8845-BD4E-CB4CCA059FC4}" type="datetimeFigureOut">
               <a:rPr lang="en-US" smtClean="0"/>
-              <a:t>3/10/2026</a:t>
+              <a:t>4/10/2026</a:t>
             </a:fld>
             <a:endParaRPr lang="en-US"/>
           </a:p>
@@ -2154,7 +2083,7 @@
           <a:p>
             <a:fld id="{5BCAD085-E8A6-8845-BD4E-CB4CCA059FC4}" type="datetimeFigureOut">
               <a:rPr lang="en-US" smtClean="0"/>
-              <a:t>3/10/2026</a:t>
+              <a:t>4/10/2026</a:t>
             </a:fld>
             <a:endParaRPr lang="en-US"/>
           </a:p>
@@ -2399,7 +2328,7 @@
           <a:p>
             <a:fld id="{5BCAD085-E8A6-8845-BD4E-CB4CCA059FC4}" type="datetimeFigureOut">
               <a:rPr lang="en-US" smtClean="0"/>
-              <a:t>3/10/2026</a:t>
+              <a:t>4/10/2026</a:t>
             </a:fld>
             <a:endParaRPr lang="en-US"/>
           </a:p>
@@ -2684,7 +2613,7 @@
           <a:p>
             <a:fld id="{5BCAD085-E8A6-8845-BD4E-CB4CCA059FC4}" type="datetimeFigureOut">
               <a:rPr lang="en-US" smtClean="0"/>
-              <a:t>3/10/2026</a:t>
+              <a:t>4/10/2026</a:t>
             </a:fld>
             <a:endParaRPr lang="en-US"/>
           </a:p>
@@ -3103,7 +3032,7 @@
           <a:p>
             <a:fld id="{5BCAD085-E8A6-8845-BD4E-CB4CCA059FC4}" type="datetimeFigureOut">
               <a:rPr lang="en-US" smtClean="0"/>
-              <a:t>3/10/2026</a:t>
+              <a:t>4/10/2026</a:t>
             </a:fld>
             <a:endParaRPr lang="en-US"/>
           </a:p>
@@ -3220,7 +3149,7 @@
           <a:p>
             <a:fld id="{5BCAD085-E8A6-8845-BD4E-CB4CCA059FC4}" type="datetimeFigureOut">
               <a:rPr lang="en-US" smtClean="0"/>
-              <a:t>3/10/2026</a:t>
+              <a:t>4/10/2026</a:t>
             </a:fld>
             <a:endParaRPr lang="en-US"/>
           </a:p>
@@ -3315,7 +3244,7 @@
           <a:p>
             <a:fld id="{5BCAD085-E8A6-8845-BD4E-CB4CCA059FC4}" type="datetimeFigureOut">
               <a:rPr lang="en-US" smtClean="0"/>
-              <a:t>3/10/2026</a:t>
+              <a:t>4/10/2026</a:t>
             </a:fld>
             <a:endParaRPr lang="en-US"/>
           </a:p>
@@ -3590,7 +3519,7 @@
           <a:p>
             <a:fld id="{5BCAD085-E8A6-8845-BD4E-CB4CCA059FC4}" type="datetimeFigureOut">
               <a:rPr lang="en-US" smtClean="0"/>
-              <a:t>3/10/2026</a:t>
+              <a:t>4/10/2026</a:t>
             </a:fld>
             <a:endParaRPr lang="en-US"/>
           </a:p>
@@ -3842,7 +3771,7 @@
           <a:p>
             <a:fld id="{5BCAD085-E8A6-8845-BD4E-CB4CCA059FC4}" type="datetimeFigureOut">
               <a:rPr lang="en-US" smtClean="0"/>
-              <a:t>3/10/2026</a:t>
+              <a:t>4/10/2026</a:t>
             </a:fld>
             <a:endParaRPr lang="en-US"/>
           </a:p>
@@ -4053,7 +3982,7 @@
           <a:p>
             <a:fld id="{5BCAD085-E8A6-8845-BD4E-CB4CCA059FC4}" type="datetimeFigureOut">
               <a:rPr lang="en-US" smtClean="0"/>
-              <a:t>3/10/2026</a:t>
+              <a:t>4/10/2026</a:t>
             </a:fld>
             <a:endParaRPr lang="en-US"/>
           </a:p>
@@ -6930,6 +6859,7 @@
               </a:defRPr>
             </a:pPr>
             <a:r>
+              <a:rPr dirty="0"/>
               <a:t>🎬 Live Demonstration</a:t>
             </a:r>
           </a:p>
@@ -7332,83 +7262,63 @@
       </p:grpSpPr>
       <p:sp>
         <p:nvSpPr>
-          <p:cNvPr id="2" name="TextBox 1"/>
-          <p:cNvSpPr txBox="1"/>
-          <p:nvPr/>
-        </p:nvSpPr>
-        <p:spPr>
-          <a:xfrm>
-            <a:off x="1828800" y="2286000"/>
-            <a:ext cx="5486400" cy="1828800"/>
-          </a:xfrm>
-          <a:prstGeom prst="rect">
-            <a:avLst/>
-          </a:prstGeom>
-          <a:noFill/>
-        </p:spPr>
-        <p:txBody>
-          <a:bodyPr wrap="none">
-            <a:spAutoFit/>
-          </a:bodyPr>
-          <a:lstStyle/>
-          <a:p>
-            <a:pPr algn="ctr">
-              <a:defRPr sz="7200" b="1">
+          <p:cNvPr id="2" name="Title 1"/>
+          <p:cNvSpPr>
+            <a:spLocks noGrp="1"/>
+          </p:cNvSpPr>
+          <p:nvPr>
+            <p:ph type="title"/>
+          </p:nvPr>
+        </p:nvSpPr>
+        <p:spPr/>
+        <p:txBody>
+          <a:bodyPr>
+            <a:normAutofit fontScale="90000"/>
+          </a:bodyPr>
+          <a:lstStyle/>
+          <a:p>
+            <a:r>
+              <a:rPr lang="en-US" sz="4000" b="1" dirty="0">
                 <a:solidFill>
                   <a:srgbClr val="2E74B5"/>
                 </a:solidFill>
-              </a:defRPr>
-            </a:pPr>
-            <a:r>
-              <a:t>Questions?</a:t>
-            </a:r>
-          </a:p>
-        </p:txBody>
-      </p:sp>
-      <p:sp>
-        <p:nvSpPr>
-          <p:cNvPr id="3" name="TextBox 2"/>
-          <p:cNvSpPr txBox="1"/>
-          <p:nvPr/>
-        </p:nvSpPr>
-        <p:spPr>
-          <a:xfrm>
-            <a:off x="1828800" y="4572000"/>
-            <a:ext cx="5486400" cy="914400"/>
-          </a:xfrm>
-          <a:prstGeom prst="rect">
-            <a:avLst/>
-          </a:prstGeom>
-          <a:noFill/>
-        </p:spPr>
-        <p:txBody>
-          <a:bodyPr wrap="none">
-            <a:spAutoFit/>
-          </a:bodyPr>
-          <a:lstStyle/>
-          <a:p>
-            <a:pPr algn="ctr">
-              <a:defRPr sz="2000">
-                <a:solidFill>
-                  <a:srgbClr val="FFFFFF"/>
-                </a:solidFill>
-              </a:defRPr>
-            </a:pPr>
-            <a:r>
-              <a:t>Thank you for your attention!</a:t>
-            </a:r>
-          </a:p>
-          <a:p>
-            <a:r>
-              <a:t>[your.email@university.edu]</a:t>
-            </a:r>
-          </a:p>
-        </p:txBody>
-      </p:sp>
+                <a:latin typeface="+mn-lt"/>
+                <a:ea typeface="+mn-ea"/>
+                <a:cs typeface="+mn-cs"/>
+              </a:rPr>
+              <a:t>Mathematical Proof: Ensemble Confusion Matrix</a:t>
+            </a:r>
+          </a:p>
+        </p:txBody>
+      </p:sp>
+      <p:pic>
+        <p:nvPicPr>
+          <p:cNvPr id="3" name="Picture 2" descr="doc_confusion_matrix.png"/>
+          <p:cNvPicPr>
+            <a:picLocks noChangeAspect="1"/>
+          </p:cNvPicPr>
+          <p:nvPr/>
+        </p:nvPicPr>
+        <p:blipFill>
+          <a:blip r:embed="rId3"/>
+          <a:stretch>
+            <a:fillRect/>
+          </a:stretch>
+        </p:blipFill>
+        <p:spPr>
+          <a:xfrm>
+            <a:off x="1371600" y="1828800"/>
+            <a:ext cx="5943600" cy="4245429"/>
+          </a:xfrm>
+          <a:prstGeom prst="rect">
+            <a:avLst/>
+          </a:prstGeom>
+        </p:spPr>
+      </p:pic>
     </p:spTree>
   </p:cSld>
   <p:clrMapOvr>
-    <a:masterClrMapping/>
+    <a:overrideClrMapping bg1="lt1" tx1="dk1" bg2="lt2" tx2="dk2" accent1="accent1" accent2="accent2" accent3="accent3" accent4="accent4" accent5="accent5" accent6="accent6" hlink="hlink" folHlink="folHlink"/>
   </p:clrMapOvr>
 </p:sld>
 </file>
@@ -7416,6 +7326,14 @@
 <file path=ppt/slides/slide18.xml><?xml version="1.0" encoding="utf-8"?>
 <p:sld xmlns:a="http://schemas.openxmlformats.org/drawingml/2006/main" xmlns:r="http://schemas.openxmlformats.org/officeDocument/2006/relationships" xmlns:p="http://schemas.openxmlformats.org/presentationml/2006/main">
   <p:cSld>
+    <p:bg>
+      <p:bgPr>
+        <a:solidFill>
+          <a:srgbClr val="1E1E1E"/>
+        </a:solidFill>
+        <a:effectLst/>
+      </p:bgPr>
+    </p:bg>
     <p:spTree>
       <p:nvGrpSpPr>
         <p:cNvPr id="1" name=""/>
@@ -7442,25 +7360,27 @@
         </p:nvSpPr>
         <p:spPr/>
         <p:txBody>
-          <a:bodyPr/>
-          <a:lstStyle/>
-          <a:p>
-            <a:r>
-              <a:t>Mathematical Proof: Ensemble Confusion Matrix</a:t>
+          <a:bodyPr>
+            <a:normAutofit fontScale="90000"/>
+          </a:bodyPr>
+          <a:lstStyle/>
+          <a:p>
+            <a:r>
+              <a:t>Predictive Boundaries: ROC AUC Curve</a:t>
             </a:r>
           </a:p>
         </p:txBody>
       </p:sp>
       <p:pic>
         <p:nvPicPr>
-          <p:cNvPr id="3" name="Picture 2" descr="doc_confusion_matrix.png"/>
+          <p:cNvPr id="3" name="Picture 2" descr="doc_roc_curve.png"/>
           <p:cNvPicPr>
             <a:picLocks noChangeAspect="1"/>
           </p:cNvPicPr>
           <p:nvPr/>
         </p:nvPicPr>
         <p:blipFill>
-          <a:blip r:embed="rId2"/>
+          <a:blip r:embed="rId3"/>
           <a:stretch>
             <a:fillRect/>
           </a:stretch>
@@ -7478,7 +7398,7 @@
     </p:spTree>
   </p:cSld>
   <p:clrMapOvr>
-    <a:masterClrMapping/>
+    <a:overrideClrMapping bg1="lt1" tx1="dk1" bg2="lt2" tx2="dk2" accent1="accent1" accent2="accent2" accent3="accent3" accent4="accent4" accent5="accent5" accent6="accent6" hlink="hlink" folHlink="folHlink"/>
   </p:clrMapOvr>
 </p:sld>
 </file>
@@ -7486,6 +7406,11 @@
 <file path=ppt/slides/slide19.xml><?xml version="1.0" encoding="utf-8"?>
 <p:sld xmlns:a="http://schemas.openxmlformats.org/drawingml/2006/main" xmlns:r="http://schemas.openxmlformats.org/officeDocument/2006/relationships" xmlns:p="http://schemas.openxmlformats.org/presentationml/2006/main">
   <p:cSld>
+    <p:bg>
+      <p:bgRef idx="1001">
+        <a:schemeClr val="bg1"/>
+      </p:bgRef>
+    </p:bg>
     <p:spTree>
       <p:nvGrpSpPr>
         <p:cNvPr id="1" name=""/>
@@ -7512,33 +7437,35 @@
         </p:nvSpPr>
         <p:spPr/>
         <p:txBody>
-          <a:bodyPr/>
-          <a:lstStyle/>
-          <a:p>
-            <a:r>
-              <a:t>Predictive Boundaries: ROC AUC Curve</a:t>
+          <a:bodyPr>
+            <a:normAutofit fontScale="90000"/>
+          </a:bodyPr>
+          <a:lstStyle/>
+          <a:p>
+            <a:r>
+              <a:t>Explainable AI: Stage 2 Feature Importance</a:t>
             </a:r>
           </a:p>
         </p:txBody>
       </p:sp>
       <p:pic>
         <p:nvPicPr>
-          <p:cNvPr id="3" name="Picture 2" descr="doc_roc_curve.png"/>
+          <p:cNvPr id="3" name="Picture 2" descr="doc_feature_importance.png"/>
           <p:cNvPicPr>
             <a:picLocks noChangeAspect="1"/>
           </p:cNvPicPr>
           <p:nvPr/>
         </p:nvPicPr>
         <p:blipFill>
-          <a:blip r:embed="rId2"/>
+          <a:blip r:embed="rId3"/>
           <a:stretch>
             <a:fillRect/>
           </a:stretch>
         </p:blipFill>
         <p:spPr>
           <a:xfrm>
-            <a:off x="1371600" y="1828800"/>
-            <a:ext cx="5943600" cy="4245429"/>
+            <a:off x="914400" y="1828800"/>
+            <a:ext cx="6858000" cy="4572000"/>
           </a:xfrm>
           <a:prstGeom prst="rect">
             <a:avLst/>
@@ -7548,7 +7475,7 @@
     </p:spTree>
   </p:cSld>
   <p:clrMapOvr>
-    <a:masterClrMapping/>
+    <a:overrideClrMapping bg1="lt1" tx1="dk1" bg2="lt2" tx2="dk2" accent1="accent1" accent2="accent2" accent3="accent3" accent4="accent4" accent5="accent5" accent6="accent6" hlink="hlink" folHlink="folHlink"/>
   </p:clrMapOvr>
 </p:sld>
 </file>
@@ -7815,69 +7742,6 @@
           <a:lstStyle/>
           <a:p>
             <a:r>
-              <a:t>Explainable AI: Stage 2 Feature Importance</a:t>
-            </a:r>
-          </a:p>
-        </p:txBody>
-      </p:sp>
-      <p:pic>
-        <p:nvPicPr>
-          <p:cNvPr id="3" name="Picture 2" descr="doc_feature_importance.png"/>
-          <p:cNvPicPr>
-            <a:picLocks noChangeAspect="1"/>
-          </p:cNvPicPr>
-          <p:nvPr/>
-        </p:nvPicPr>
-        <p:blipFill>
-          <a:blip r:embed="rId2"/>
-          <a:stretch>
-            <a:fillRect/>
-          </a:stretch>
-        </p:blipFill>
-        <p:spPr>
-          <a:xfrm>
-            <a:off x="914400" y="1828800"/>
-            <a:ext cx="6858000" cy="4572000"/>
-          </a:xfrm>
-          <a:prstGeom prst="rect">
-            <a:avLst/>
-          </a:prstGeom>
-        </p:spPr>
-      </p:pic>
-    </p:spTree>
-  </p:cSld>
-  <p:clrMapOvr>
-    <a:masterClrMapping/>
-  </p:clrMapOvr>
-</p:sld>
-</file>
-
-<file path=ppt/slides/slide21.xml><?xml version="1.0" encoding="utf-8"?>
-<p:sld xmlns:a="http://schemas.openxmlformats.org/drawingml/2006/main" xmlns:p="http://schemas.openxmlformats.org/presentationml/2006/main" xmlns:r="http://schemas.openxmlformats.org/officeDocument/2006/relationships">
-  <p:cSld>
-    <p:spTree>
-      <p:nvGrpSpPr>
-        <p:cNvPr id="1" name=""/>
-        <p:cNvGrpSpPr/>
-        <p:nvPr/>
-      </p:nvGrpSpPr>
-      <p:grpSpPr/>
-      <p:sp>
-        <p:nvSpPr>
-          <p:cNvPr id="2" name="Title 1"/>
-          <p:cNvSpPr>
-            <a:spLocks noGrp="1"/>
-          </p:cNvSpPr>
-          <p:nvPr>
-            <p:ph type="title"/>
-          </p:nvPr>
-        </p:nvSpPr>
-        <p:spPr/>
-        <p:txBody>
-          <a:bodyPr/>
-          <a:lstStyle/>
-          <a:p>
-            <a:r>
               <a:t>March 2026 Semantic Model Refit</a:t>
             </a:r>
           </a:p>
@@ -7895,14 +7759,18 @@
         </p:nvSpPr>
         <p:spPr/>
         <p:txBody>
-          <a:bodyPr/>
+          <a:bodyPr>
+            <a:normAutofit fontScale="92500" lnSpcReduction="20000"/>
+          </a:bodyPr>
           <a:lstStyle/>
           <a:p>
             <a:r>
               <a:t>SentinURL's offline ML accuracy was boosted to 89.1% by retraining the AI on 1 Million links using new deep semantic features:</a:t>
             </a:r>
           </a:p>
-          <a:p/>
+          <a:p>
+            <a:endParaRPr/>
+          </a:p>
           <a:p>
             <a:r>
               <a:t>Vowel-to-Consonant tracking for Gibson-like gibberish domain detection.</a:t>
@@ -9126,7 +8994,7 @@
         <p:spPr>
           <a:xfrm>
             <a:off x="4754880" y="2926080"/>
-            <a:ext cx="3840480" cy="1051560"/>
+            <a:ext cx="4214744" cy="907941"/>
           </a:xfrm>
           <a:prstGeom prst="rect">
             <a:avLst/>
@@ -9150,6 +9018,7 @@
               </a:defRPr>
             </a:pPr>
             <a:r>
+              <a:rPr dirty="0"/>
               <a:t>• Collected 108K URLs from PhishTank, OpenPhish, Alexa, Cisco</a:t>
             </a:r>
           </a:p>
@@ -9165,8 +9034,10 @@
               </a:defRPr>
             </a:pPr>
             <a:r>
-              <a:t>• KNIME: CSV Reader, Concatenate &amp; Dupe Filters used to merge datasets</a:t>
-            </a:r>
+              <a:rPr dirty="0"/>
+              <a:t>• KNIME: CSV Reader, Concatenate &amp; Dupe Filters used to merge</a:t>
+            </a:r>
+            <a:endParaRPr lang="en-US" dirty="0"/>
           </a:p>
           <a:p>
             <a:pPr>
@@ -9180,102 +9051,14 @@
               </a:defRPr>
             </a:pPr>
             <a:r>
-              <a:t>• Feature engineering: 32 handcrafted features extracted</a:t>
-            </a:r>
-          </a:p>
-        </p:txBody>
-      </p:sp>
-      <p:sp>
-        <p:nvSpPr>
-          <p:cNvPr id="9" name="TextBox 8"/>
-          <p:cNvSpPr txBox="1"/>
-          <p:nvPr/>
-        </p:nvSpPr>
-        <p:spPr>
-          <a:xfrm>
-            <a:off x="640080" y="4114800"/>
-            <a:ext cx="1188720" cy="457200"/>
-          </a:xfrm>
-          <a:prstGeom prst="rect">
-            <a:avLst/>
-          </a:prstGeom>
-          <a:noFill/>
-        </p:spPr>
-        <p:txBody>
-          <a:bodyPr wrap="none">
-            <a:spAutoFit/>
-          </a:bodyPr>
-          <a:lstStyle/>
-          <a:p>
-            <a:pPr>
-              <a:defRPr sz="1600" b="1">
-                <a:solidFill>
-                  <a:srgbClr val="2E74B5"/>
-                </a:solidFill>
-              </a:defRPr>
-            </a:pPr>
-            <a:r>
-              <a:t>Month 3</a:t>
-            </a:r>
-          </a:p>
-        </p:txBody>
-      </p:sp>
-      <p:sp>
-        <p:nvSpPr>
-          <p:cNvPr id="10" name="TextBox 9"/>
-          <p:cNvSpPr txBox="1"/>
-          <p:nvPr/>
-        </p:nvSpPr>
-        <p:spPr>
-          <a:xfrm>
-            <a:off x="2011680" y="4114800"/>
-            <a:ext cx="2560320" cy="457200"/>
-          </a:xfrm>
-          <a:prstGeom prst="rect">
-            <a:avLst/>
-          </a:prstGeom>
-          <a:noFill/>
-        </p:spPr>
-        <p:txBody>
-          <a:bodyPr wrap="none">
-            <a:spAutoFit/>
-          </a:bodyPr>
-          <a:lstStyle/>
-          <a:p>
-            <a:pPr>
-              <a:defRPr sz="1700" b="1">
-                <a:solidFill>
-                  <a:srgbClr val="FFFFFF"/>
-                </a:solidFill>
-              </a:defRPr>
-            </a:pPr>
-            <a:r>
-              <a:t>Model Development &amp; Tuning</a:t>
-            </a:r>
-          </a:p>
-        </p:txBody>
-      </p:sp>
-      <p:sp>
-        <p:nvSpPr>
-          <p:cNvPr id="11" name="TextBox 10"/>
-          <p:cNvSpPr txBox="1"/>
-          <p:nvPr/>
-        </p:nvSpPr>
-        <p:spPr>
-          <a:xfrm>
-            <a:off x="4754880" y="4160520"/>
-            <a:ext cx="3840480" cy="1051560"/>
-          </a:xfrm>
-          <a:prstGeom prst="rect">
-            <a:avLst/>
-          </a:prstGeom>
-          <a:noFill/>
-        </p:spPr>
-        <p:txBody>
-          <a:bodyPr wrap="none">
-            <a:spAutoFit/>
-          </a:bodyPr>
-          <a:lstStyle/>
+              <a:rPr lang="en-US" dirty="0"/>
+              <a:t>  </a:t>
+            </a:r>
+            <a:r>
+              <a:rPr dirty="0"/>
+              <a:t> datasets</a:t>
+            </a:r>
+          </a:p>
           <a:p>
             <a:pPr>
               <a:spcBef>
@@ -9288,9 +9071,103 @@
               </a:defRPr>
             </a:pPr>
             <a:r>
-              <a:t>• Baseline Random Forest: 95.8% accuracy</a:t>
-            </a:r>
-          </a:p>
+              <a:rPr dirty="0"/>
+              <a:t>• Feature engineering: 32 handcrafted features extracted</a:t>
+            </a:r>
+          </a:p>
+        </p:txBody>
+      </p:sp>
+      <p:sp>
+        <p:nvSpPr>
+          <p:cNvPr id="9" name="TextBox 8"/>
+          <p:cNvSpPr txBox="1"/>
+          <p:nvPr/>
+        </p:nvSpPr>
+        <p:spPr>
+          <a:xfrm>
+            <a:off x="640080" y="4114800"/>
+            <a:ext cx="1188720" cy="457200"/>
+          </a:xfrm>
+          <a:prstGeom prst="rect">
+            <a:avLst/>
+          </a:prstGeom>
+          <a:noFill/>
+        </p:spPr>
+        <p:txBody>
+          <a:bodyPr wrap="none">
+            <a:spAutoFit/>
+          </a:bodyPr>
+          <a:lstStyle/>
+          <a:p>
+            <a:pPr>
+              <a:defRPr sz="1600" b="1">
+                <a:solidFill>
+                  <a:srgbClr val="2E74B5"/>
+                </a:solidFill>
+              </a:defRPr>
+            </a:pPr>
+            <a:r>
+              <a:t>Month 3</a:t>
+            </a:r>
+          </a:p>
+        </p:txBody>
+      </p:sp>
+      <p:sp>
+        <p:nvSpPr>
+          <p:cNvPr id="10" name="TextBox 9"/>
+          <p:cNvSpPr txBox="1"/>
+          <p:nvPr/>
+        </p:nvSpPr>
+        <p:spPr>
+          <a:xfrm>
+            <a:off x="2011680" y="4114800"/>
+            <a:ext cx="2560320" cy="457200"/>
+          </a:xfrm>
+          <a:prstGeom prst="rect">
+            <a:avLst/>
+          </a:prstGeom>
+          <a:noFill/>
+        </p:spPr>
+        <p:txBody>
+          <a:bodyPr wrap="none">
+            <a:spAutoFit/>
+          </a:bodyPr>
+          <a:lstStyle/>
+          <a:p>
+            <a:pPr>
+              <a:defRPr sz="1700" b="1">
+                <a:solidFill>
+                  <a:srgbClr val="FFFFFF"/>
+                </a:solidFill>
+              </a:defRPr>
+            </a:pPr>
+            <a:r>
+              <a:t>Model Development &amp; Tuning</a:t>
+            </a:r>
+          </a:p>
+        </p:txBody>
+      </p:sp>
+      <p:sp>
+        <p:nvSpPr>
+          <p:cNvPr id="11" name="TextBox 10"/>
+          <p:cNvSpPr txBox="1"/>
+          <p:nvPr/>
+        </p:nvSpPr>
+        <p:spPr>
+          <a:xfrm>
+            <a:off x="4754880" y="4160520"/>
+            <a:ext cx="3840480" cy="1051560"/>
+          </a:xfrm>
+          <a:prstGeom prst="rect">
+            <a:avLst/>
+          </a:prstGeom>
+          <a:noFill/>
+        </p:spPr>
+        <p:txBody>
+          <a:bodyPr wrap="none">
+            <a:spAutoFit/>
+          </a:bodyPr>
+          <a:lstStyle/>
           <a:p>
             <a:pPr>
               <a:spcBef>
@@ -9303,7 +9180,7 @@
               </a:defRPr>
             </a:pPr>
             <a:r>
-              <a:t>• CatBoost (HistGradientBoosting) with grid search</a:t>
+              <a:t>• Baseline Random Forest: 95.8% accuracy</a:t>
             </a:r>
           </a:p>
           <a:p>
@@ -9318,6 +9195,21 @@
               </a:defRPr>
             </a:pPr>
             <a:r>
+              <a:t>• CatBoost (HistGradientBoosting) with grid search</a:t>
+            </a:r>
+          </a:p>
+          <a:p>
+            <a:pPr>
+              <a:spcBef>
+                <a:spcPts val="200"/>
+              </a:spcBef>
+              <a:defRPr sz="1200">
+                <a:solidFill>
+                  <a:srgbClr val="BDC3C7"/>
+                </a:solidFill>
+              </a:defRPr>
+            </a:pPr>
+            <a:r>
               <a:t>• TF-IDF + Ensemble fusion:99.4% accuracy achieved</a:t>
             </a:r>
           </a:p>
@@ -9367,7 +9259,7 @@
         <p:spPr>
           <a:xfrm>
             <a:off x="2011680" y="5349240"/>
-            <a:ext cx="2560320" cy="457200"/>
+            <a:ext cx="2056973" cy="615553"/>
           </a:xfrm>
           <a:prstGeom prst="rect">
             <a:avLst/>
@@ -9388,7 +9280,22 @@
               </a:defRPr>
             </a:pPr>
             <a:r>
-              <a:t>Testing, Deployment &amp; Refinement</a:t>
+              <a:rPr dirty="0"/>
+              <a:t>Testing, Deployment</a:t>
+            </a:r>
+            <a:endParaRPr lang="en-US" dirty="0"/>
+          </a:p>
+          <a:p>
+            <a:pPr>
+              <a:defRPr sz="1700" b="1">
+                <a:solidFill>
+                  <a:srgbClr val="FFFFFF"/>
+                </a:solidFill>
+              </a:defRPr>
+            </a:pPr>
+            <a:r>
+              <a:rPr dirty="0"/>
+              <a:t>&amp; Refinement</a:t>
             </a:r>
           </a:p>
         </p:txBody>
@@ -12359,4 +12266,133 @@
     </a:ext>
   </a:extLst>
 </a:theme>
+</file>
+
+<file path=ppt/theme/themeOverride1.xml><?xml version="1.0" encoding="utf-8"?>
+<a:themeOverride xmlns:a="http://schemas.openxmlformats.org/drawingml/2006/main">
+  <a:clrScheme name="Office">
+    <a:dk1>
+      <a:sysClr val="windowText" lastClr="000000"/>
+    </a:dk1>
+    <a:lt1>
+      <a:sysClr val="window" lastClr="FFFFFF"/>
+    </a:lt1>
+    <a:dk2>
+      <a:srgbClr val="1F497D"/>
+    </a:dk2>
+    <a:lt2>
+      <a:srgbClr val="EEECE1"/>
+    </a:lt2>
+    <a:accent1>
+      <a:srgbClr val="4F81BD"/>
+    </a:accent1>
+    <a:accent2>
+      <a:srgbClr val="C0504D"/>
+    </a:accent2>
+    <a:accent3>
+      <a:srgbClr val="9BBB59"/>
+    </a:accent3>
+    <a:accent4>
+      <a:srgbClr val="8064A2"/>
+    </a:accent4>
+    <a:accent5>
+      <a:srgbClr val="4BACC6"/>
+    </a:accent5>
+    <a:accent6>
+      <a:srgbClr val="F79646"/>
+    </a:accent6>
+    <a:hlink>
+      <a:srgbClr val="0000FF"/>
+    </a:hlink>
+    <a:folHlink>
+      <a:srgbClr val="800080"/>
+    </a:folHlink>
+  </a:clrScheme>
+</a:themeOverride>
+</file>
+
+<file path=ppt/theme/themeOverride2.xml><?xml version="1.0" encoding="utf-8"?>
+<a:themeOverride xmlns:a="http://schemas.openxmlformats.org/drawingml/2006/main">
+  <a:clrScheme name="Office">
+    <a:dk1>
+      <a:sysClr val="windowText" lastClr="000000"/>
+    </a:dk1>
+    <a:lt1>
+      <a:sysClr val="window" lastClr="FFFFFF"/>
+    </a:lt1>
+    <a:dk2>
+      <a:srgbClr val="1F497D"/>
+    </a:dk2>
+    <a:lt2>
+      <a:srgbClr val="EEECE1"/>
+    </a:lt2>
+    <a:accent1>
+      <a:srgbClr val="4F81BD"/>
+    </a:accent1>
+    <a:accent2>
+      <a:srgbClr val="C0504D"/>
+    </a:accent2>
+    <a:accent3>
+      <a:srgbClr val="9BBB59"/>
+    </a:accent3>
+    <a:accent4>
+      <a:srgbClr val="8064A2"/>
+    </a:accent4>
+    <a:accent5>
+      <a:srgbClr val="4BACC6"/>
+    </a:accent5>
+    <a:accent6>
+      <a:srgbClr val="F79646"/>
+    </a:accent6>
+    <a:hlink>
+      <a:srgbClr val="0000FF"/>
+    </a:hlink>
+    <a:folHlink>
+      <a:srgbClr val="800080"/>
+    </a:folHlink>
+  </a:clrScheme>
+</a:themeOverride>
+</file>
+
+<file path=ppt/theme/themeOverride3.xml><?xml version="1.0" encoding="utf-8"?>
+<a:themeOverride xmlns:a="http://schemas.openxmlformats.org/drawingml/2006/main">
+  <a:clrScheme name="Office">
+    <a:dk1>
+      <a:sysClr val="windowText" lastClr="000000"/>
+    </a:dk1>
+    <a:lt1>
+      <a:sysClr val="window" lastClr="FFFFFF"/>
+    </a:lt1>
+    <a:dk2>
+      <a:srgbClr val="1F497D"/>
+    </a:dk2>
+    <a:lt2>
+      <a:srgbClr val="EEECE1"/>
+    </a:lt2>
+    <a:accent1>
+      <a:srgbClr val="4F81BD"/>
+    </a:accent1>
+    <a:accent2>
+      <a:srgbClr val="C0504D"/>
+    </a:accent2>
+    <a:accent3>
+      <a:srgbClr val="9BBB59"/>
+    </a:accent3>
+    <a:accent4>
+      <a:srgbClr val="8064A2"/>
+    </a:accent4>
+    <a:accent5>
+      <a:srgbClr val="4BACC6"/>
+    </a:accent5>
+    <a:accent6>
+      <a:srgbClr val="F79646"/>
+    </a:accent6>
+    <a:hlink>
+      <a:srgbClr val="0000FF"/>
+    </a:hlink>
+    <a:folHlink>
+      <a:srgbClr val="800080"/>
+    </a:folHlink>
+  </a:clrScheme>
+</a:themeOverride>
 </file>
</xml_diff>